<commit_message>
Movers sparkline review: old row picked, store names in caps
Co-Authored-By: Claude Opus 5.5 <noreply@anthropic.com>
Claude-Session: https://claude.ai/code/session_01Xa4nFVxuQGXmHARGph9WhS
</commit_message>
<xml_diff>
--- a/day2-deck/decks/Movers Sparklines - Review.pptx
+++ b/day2-deck/decks/Movers Sparklines - Review.pptx
@@ -19139,7 +19139,7 @@
                 <a:ea typeface="Inter" pitchFamily="34" charset="-122"/>
                 <a:cs typeface="Inter" pitchFamily="34" charset="-120"/>
               </a:rPr>
-              <a:t>Lincoln</a:t>
+              <a:t>LINCOLN</a:t>
             </a:r>
             <a:endParaRPr lang="en-US" sz="1400" dirty="0"/>
           </a:p>
@@ -19351,7 +19351,7 @@
                 <a:ea typeface="Inter" pitchFamily="34" charset="-122"/>
                 <a:cs typeface="Inter" pitchFamily="34" charset="-120"/>
               </a:rPr>
-              <a:t>Cadillac</a:t>
+              <a:t>CADILLAC</a:t>
             </a:r>
             <a:endParaRPr lang="en-US" sz="1400" dirty="0"/>
           </a:p>
@@ -19583,7 +19583,7 @@
                 <a:ea typeface="Inter" pitchFamily="34" charset="-122"/>
                 <a:cs typeface="Inter" pitchFamily="34" charset="-120"/>
               </a:rPr>
-              <a:t>Subaru St George</a:t>
+              <a:t>SUBARU ST GEORGE</a:t>
             </a:r>
             <a:endParaRPr lang="en-US" sz="1400" dirty="0"/>
           </a:p>
@@ -19795,7 +19795,7 @@
                 <a:ea typeface="Inter" pitchFamily="34" charset="-122"/>
                 <a:cs typeface="Inter" pitchFamily="34" charset="-120"/>
               </a:rPr>
-              <a:t>GMC Prescott</a:t>
+              <a:t>GMC PRESCOTT</a:t>
             </a:r>
             <a:endParaRPr lang="en-US" sz="1400" dirty="0"/>
           </a:p>
@@ -20027,7 +20027,7 @@
                 <a:ea typeface="Inter" pitchFamily="34" charset="-122"/>
                 <a:cs typeface="Inter" pitchFamily="34" charset="-120"/>
               </a:rPr>
-              <a:t>Subaru Prescott</a:t>
+              <a:t>SUBARU PRESCOTT</a:t>
             </a:r>
             <a:endParaRPr lang="en-US" sz="1400" dirty="0"/>
           </a:p>
@@ -20318,7 +20318,7 @@
                 <a:ea typeface="Inter" pitchFamily="34" charset="-122"/>
                 <a:cs typeface="Inter" pitchFamily="34" charset="-120"/>
               </a:rPr>
-              <a:t>Hyundai St George</a:t>
+              <a:t>HYUNDAI ST GEORGE</a:t>
             </a:r>
             <a:endParaRPr lang="en-US" sz="1400" dirty="0"/>
           </a:p>
@@ -20530,7 +20530,7 @@
                 <a:ea typeface="Inter" pitchFamily="34" charset="-122"/>
                 <a:cs typeface="Inter" pitchFamily="34" charset="-120"/>
               </a:rPr>
-              <a:t>Audi Reno</a:t>
+              <a:t>AUDI RENO</a:t>
             </a:r>
             <a:endParaRPr lang="en-US" sz="1400" dirty="0"/>
           </a:p>
@@ -20762,7 +20762,7 @@
                 <a:ea typeface="Inter" pitchFamily="34" charset="-122"/>
                 <a:cs typeface="Inter" pitchFamily="34" charset="-120"/>
               </a:rPr>
-              <a:t>VW Henderson</a:t>
+              <a:t>VW HENDERSON</a:t>
             </a:r>
             <a:endParaRPr lang="en-US" sz="1400" dirty="0"/>
           </a:p>
@@ -20974,7 +20974,7 @@
                 <a:ea typeface="Inter" pitchFamily="34" charset="-122"/>
                 <a:cs typeface="Inter" pitchFamily="34" charset="-120"/>
               </a:rPr>
-              <a:t>CDJR Post Falls</a:t>
+              <a:t>CDJR POST FALLS</a:t>
             </a:r>
             <a:endParaRPr lang="en-US" sz="1400" dirty="0"/>
           </a:p>
@@ -21206,7 +21206,7 @@
                 <a:ea typeface="Inter" pitchFamily="34" charset="-122"/>
                 <a:cs typeface="Inter" pitchFamily="34" charset="-120"/>
               </a:rPr>
-              <a:t>Kia LV</a:t>
+              <a:t>KIA LV</a:t>
             </a:r>
             <a:endParaRPr lang="en-US" sz="1400" dirty="0"/>
           </a:p>
@@ -21497,7 +21497,7 @@
                 <a:ea typeface="Inter" pitchFamily="34" charset="-122"/>
                 <a:cs typeface="Inter" pitchFamily="34" charset="-120"/>
               </a:rPr>
-              <a:t>Audi Henderson</a:t>
+              <a:t>AUDI HENDERSON</a:t>
             </a:r>
             <a:endParaRPr lang="en-US" sz="1400" dirty="0"/>
           </a:p>
@@ -21709,7 +21709,7 @@
                 <a:ea typeface="Inter" pitchFamily="34" charset="-122"/>
                 <a:cs typeface="Inter" pitchFamily="34" charset="-120"/>
               </a:rPr>
-              <a:t>Mazda</a:t>
+              <a:t>MAZDA</a:t>
             </a:r>
             <a:endParaRPr lang="en-US" sz="1400" dirty="0"/>
           </a:p>
@@ -21941,7 +21941,7 @@
                 <a:ea typeface="Inter" pitchFamily="34" charset="-122"/>
                 <a:cs typeface="Inter" pitchFamily="34" charset="-120"/>
               </a:rPr>
-              <a:t>Honda Flagstaff</a:t>
+              <a:t>HONDA FLAGSTAFF</a:t>
             </a:r>
             <a:endParaRPr lang="en-US" sz="1400" dirty="0"/>
           </a:p>
@@ -22153,7 +22153,7 @@
                 <a:ea typeface="Inter" pitchFamily="34" charset="-122"/>
                 <a:cs typeface="Inter" pitchFamily="34" charset="-120"/>
               </a:rPr>
-              <a:t>Kia St George</a:t>
+              <a:t>KIA ST GEORGE</a:t>
             </a:r>
             <a:endParaRPr lang="en-US" sz="1400" dirty="0"/>
           </a:p>
@@ -22385,7 +22385,7 @@
                 <a:ea typeface="Inter" pitchFamily="34" charset="-122"/>
                 <a:cs typeface="Inter" pitchFamily="34" charset="-120"/>
               </a:rPr>
-              <a:t>Nissan</a:t>
+              <a:t>NISSAN</a:t>
             </a:r>
             <a:endParaRPr lang="en-US" sz="1400" dirty="0"/>
           </a:p>
@@ -22885,7 +22885,7 @@
                 <a:ea typeface="Inter" pitchFamily="34" charset="-122"/>
                 <a:cs typeface="Inter" pitchFamily="34" charset="-120"/>
               </a:rPr>
-              <a:t>Hyundai Prescott</a:t>
+              <a:t>HYUNDAI PRESCOTT</a:t>
             </a:r>
             <a:endParaRPr lang="en-US" sz="1400" dirty="0"/>
           </a:p>
@@ -23097,7 +23097,7 @@
                 <a:ea typeface="Inter" pitchFamily="34" charset="-122"/>
                 <a:cs typeface="Inter" pitchFamily="34" charset="-120"/>
               </a:rPr>
-              <a:t>Lincoln</a:t>
+              <a:t>LINCOLN</a:t>
             </a:r>
             <a:endParaRPr lang="en-US" sz="1400" dirty="0"/>
           </a:p>
@@ -23329,7 +23329,7 @@
                 <a:ea typeface="Inter" pitchFamily="34" charset="-122"/>
                 <a:cs typeface="Inter" pitchFamily="34" charset="-120"/>
               </a:rPr>
-              <a:t>Lexus</a:t>
+              <a:t>LEXUS</a:t>
             </a:r>
             <a:endParaRPr lang="en-US" sz="1400" dirty="0"/>
           </a:p>
@@ -23541,7 +23541,7 @@
                 <a:ea typeface="Inter" pitchFamily="34" charset="-122"/>
                 <a:cs typeface="Inter" pitchFamily="34" charset="-120"/>
               </a:rPr>
-              <a:t>Audi Henderson</a:t>
+              <a:t>AUDI HENDERSON</a:t>
             </a:r>
             <a:endParaRPr lang="en-US" sz="1400" dirty="0"/>
           </a:p>
@@ -23773,7 +23773,7 @@
                 <a:ea typeface="Inter" pitchFamily="34" charset="-122"/>
                 <a:cs typeface="Inter" pitchFamily="34" charset="-120"/>
               </a:rPr>
-              <a:t>Subaru Prescott</a:t>
+              <a:t>SUBARU PRESCOTT</a:t>
             </a:r>
             <a:endParaRPr lang="en-US" sz="1400" dirty="0"/>
           </a:p>
@@ -24064,7 +24064,7 @@
                 <a:ea typeface="Inter" pitchFamily="34" charset="-122"/>
                 <a:cs typeface="Inter" pitchFamily="34" charset="-120"/>
               </a:rPr>
-              <a:t>Acura</a:t>
+              <a:t>ACURA</a:t>
             </a:r>
             <a:endParaRPr lang="en-US" sz="1400" dirty="0"/>
           </a:p>
@@ -24276,7 +24276,7 @@
                 <a:ea typeface="Inter" pitchFamily="34" charset="-122"/>
                 <a:cs typeface="Inter" pitchFamily="34" charset="-120"/>
               </a:rPr>
-              <a:t>VW St George</a:t>
+              <a:t>VW ST GEORGE</a:t>
             </a:r>
             <a:endParaRPr lang="en-US" sz="1400" dirty="0"/>
           </a:p>
@@ -24508,7 +24508,7 @@
                 <a:ea typeface="Inter" pitchFamily="34" charset="-122"/>
                 <a:cs typeface="Inter" pitchFamily="34" charset="-120"/>
               </a:rPr>
-              <a:t>VW Henderson</a:t>
+              <a:t>VW HENDERSON</a:t>
             </a:r>
             <a:endParaRPr lang="en-US" sz="1400" dirty="0"/>
           </a:p>
@@ -24720,7 +24720,7 @@
                 <a:ea typeface="Inter" pitchFamily="34" charset="-122"/>
                 <a:cs typeface="Inter" pitchFamily="34" charset="-120"/>
               </a:rPr>
-              <a:t>Audi Reno</a:t>
+              <a:t>AUDI RENO</a:t>
             </a:r>
             <a:endParaRPr lang="en-US" sz="1400" dirty="0"/>
           </a:p>
@@ -24952,7 +24952,7 @@
                 <a:ea typeface="Inter" pitchFamily="34" charset="-122"/>
                 <a:cs typeface="Inter" pitchFamily="34" charset="-120"/>
               </a:rPr>
-              <a:t>Honda North</a:t>
+              <a:t>HONDA NORTH</a:t>
             </a:r>
             <a:endParaRPr lang="en-US" sz="1400" dirty="0"/>
           </a:p>
@@ -25243,7 +25243,7 @@
                 <a:ea typeface="Inter" pitchFamily="34" charset="-122"/>
                 <a:cs typeface="Inter" pitchFamily="34" charset="-120"/>
               </a:rPr>
-              <a:t>Mazda</a:t>
+              <a:t>MAZDA</a:t>
             </a:r>
             <a:endParaRPr lang="en-US" sz="1400" dirty="0"/>
           </a:p>
@@ -25455,7 +25455,7 @@
                 <a:ea typeface="Inter" pitchFamily="34" charset="-122"/>
                 <a:cs typeface="Inter" pitchFamily="34" charset="-120"/>
               </a:rPr>
-              <a:t>Kia St George</a:t>
+              <a:t>KIA ST GEORGE</a:t>
             </a:r>
             <a:endParaRPr lang="en-US" sz="1400" dirty="0"/>
           </a:p>
@@ -25687,7 +25687,7 @@
                 <a:ea typeface="Inter" pitchFamily="34" charset="-122"/>
                 <a:cs typeface="Inter" pitchFamily="34" charset="-120"/>
               </a:rPr>
-              <a:t>LR Henderson</a:t>
+              <a:t>LR HENDERSON</a:t>
             </a:r>
             <a:endParaRPr lang="en-US" sz="1400" dirty="0"/>
           </a:p>
@@ -25899,7 +25899,7 @@
                 <a:ea typeface="Inter" pitchFamily="34" charset="-122"/>
                 <a:cs typeface="Inter" pitchFamily="34" charset="-120"/>
               </a:rPr>
-              <a:t>CDJR Post Falls</a:t>
+              <a:t>CDJR POST FALLS</a:t>
             </a:r>
             <a:endParaRPr lang="en-US" sz="1400" dirty="0"/>
           </a:p>
@@ -26151,7 +26151,7 @@
                 <a:ea typeface="Inter" pitchFamily="34" charset="-122"/>
                 <a:cs typeface="Inter" pitchFamily="34" charset="-120"/>
               </a:rPr>
-              <a:t>Hyundai Prescott</a:t>
+              <a:t>HYUNDAI PRESCOTT</a:t>
             </a:r>
             <a:endParaRPr lang="en-US" sz="1400" dirty="0"/>
           </a:p>
@@ -26651,7 +26651,7 @@
                 <a:ea typeface="Inter" pitchFamily="34" charset="-122"/>
                 <a:cs typeface="Inter" pitchFamily="34" charset="-120"/>
               </a:rPr>
-              <a:t>Hyundai Prescott</a:t>
+              <a:t>HYUNDAI PRESCOTT</a:t>
             </a:r>
             <a:endParaRPr lang="en-US" sz="1400" dirty="0"/>
           </a:p>
@@ -26863,7 +26863,7 @@
                 <a:ea typeface="Inter" pitchFamily="34" charset="-122"/>
                 <a:cs typeface="Inter" pitchFamily="34" charset="-120"/>
               </a:rPr>
-              <a:t>Lincoln</a:t>
+              <a:t>LINCOLN</a:t>
             </a:r>
             <a:endParaRPr lang="en-US" sz="1400" dirty="0"/>
           </a:p>
@@ -27095,7 +27095,7 @@
                 <a:ea typeface="Inter" pitchFamily="34" charset="-122"/>
                 <a:cs typeface="Inter" pitchFamily="34" charset="-120"/>
               </a:rPr>
-              <a:t>Lexus</a:t>
+              <a:t>LEXUS</a:t>
             </a:r>
             <a:endParaRPr lang="en-US" sz="1400" dirty="0"/>
           </a:p>
@@ -27307,7 +27307,7 @@
                 <a:ea typeface="Inter" pitchFamily="34" charset="-122"/>
                 <a:cs typeface="Inter" pitchFamily="34" charset="-120"/>
               </a:rPr>
-              <a:t>Hyundai St George</a:t>
+              <a:t>HYUNDAI ST GEORGE</a:t>
             </a:r>
             <a:endParaRPr lang="en-US" sz="1400" dirty="0"/>
           </a:p>
@@ -27539,7 +27539,7 @@
                 <a:ea typeface="Inter" pitchFamily="34" charset="-122"/>
                 <a:cs typeface="Inter" pitchFamily="34" charset="-120"/>
               </a:rPr>
-              <a:t>Toyota Prescott</a:t>
+              <a:t>TOYOTA PRESCOTT</a:t>
             </a:r>
             <a:endParaRPr lang="en-US" sz="1400" dirty="0"/>
           </a:p>
@@ -27830,7 +27830,7 @@
                 <a:ea typeface="Inter" pitchFamily="34" charset="-122"/>
                 <a:cs typeface="Inter" pitchFamily="34" charset="-120"/>
               </a:rPr>
-              <a:t>Acura</a:t>
+              <a:t>ACURA</a:t>
             </a:r>
             <a:endParaRPr lang="en-US" sz="1400" dirty="0"/>
           </a:p>
@@ -28042,7 +28042,7 @@
                 <a:ea typeface="Inter" pitchFamily="34" charset="-122"/>
                 <a:cs typeface="Inter" pitchFamily="34" charset="-120"/>
               </a:rPr>
-              <a:t>VW St George</a:t>
+              <a:t>VW ST GEORGE</a:t>
             </a:r>
             <a:endParaRPr lang="en-US" sz="1400" dirty="0"/>
           </a:p>
@@ -28274,7 +28274,7 @@
                 <a:ea typeface="Inter" pitchFamily="34" charset="-122"/>
                 <a:cs typeface="Inter" pitchFamily="34" charset="-120"/>
               </a:rPr>
-              <a:t>VW Henderson</a:t>
+              <a:t>VW HENDERSON</a:t>
             </a:r>
             <a:endParaRPr lang="en-US" sz="1400" dirty="0"/>
           </a:p>
@@ -28486,7 +28486,7 @@
                 <a:ea typeface="Inter" pitchFamily="34" charset="-122"/>
                 <a:cs typeface="Inter" pitchFamily="34" charset="-120"/>
               </a:rPr>
-              <a:t>Honda North</a:t>
+              <a:t>HONDA NORTH</a:t>
             </a:r>
             <a:endParaRPr lang="en-US" sz="1400" dirty="0"/>
           </a:p>
@@ -28718,7 +28718,7 @@
                 <a:ea typeface="Inter" pitchFamily="34" charset="-122"/>
                 <a:cs typeface="Inter" pitchFamily="34" charset="-120"/>
               </a:rPr>
-              <a:t>Audi Reno</a:t>
+              <a:t>AUDI RENO</a:t>
             </a:r>
             <a:endParaRPr lang="en-US" sz="1400" dirty="0"/>
           </a:p>
@@ -29009,7 +29009,7 @@
                 <a:ea typeface="Inter" pitchFamily="34" charset="-122"/>
                 <a:cs typeface="Inter" pitchFamily="34" charset="-120"/>
               </a:rPr>
-              <a:t>Mazda</a:t>
+              <a:t>MAZDA</a:t>
             </a:r>
             <a:endParaRPr lang="en-US" sz="1400" dirty="0"/>
           </a:p>
@@ -29221,7 +29221,7 @@
                 <a:ea typeface="Inter" pitchFamily="34" charset="-122"/>
                 <a:cs typeface="Inter" pitchFamily="34" charset="-120"/>
               </a:rPr>
-              <a:t>Kia St George</a:t>
+              <a:t>KIA ST GEORGE</a:t>
             </a:r>
             <a:endParaRPr lang="en-US" sz="1400" dirty="0"/>
           </a:p>
@@ -29473,7 +29473,7 @@
                 <a:ea typeface="Inter" pitchFamily="34" charset="-122"/>
                 <a:cs typeface="Inter" pitchFamily="34" charset="-120"/>
               </a:rPr>
-              <a:t>Hyundai Prescott</a:t>
+              <a:t>HYUNDAI PRESCOTT</a:t>
             </a:r>
             <a:endParaRPr lang="en-US" sz="1400" dirty="0"/>
           </a:p>
@@ -29685,7 +29685,7 @@
                 <a:ea typeface="Inter" pitchFamily="34" charset="-122"/>
                 <a:cs typeface="Inter" pitchFamily="34" charset="-120"/>
               </a:rPr>
-              <a:t>LR Henderson</a:t>
+              <a:t>LR HENDERSON</a:t>
             </a:r>
             <a:endParaRPr lang="en-US" sz="1400" dirty="0"/>
           </a:p>
@@ -29917,7 +29917,7 @@
                 <a:ea typeface="Inter" pitchFamily="34" charset="-122"/>
                 <a:cs typeface="Inter" pitchFamily="34" charset="-120"/>
               </a:rPr>
-              <a:t>CDJR Post Falls</a:t>
+              <a:t>CDJR POST FALLS</a:t>
             </a:r>
             <a:endParaRPr lang="en-US" sz="1400" dirty="0"/>
           </a:p>

</xml_diff>